<commit_message>
Update CSC382 Project Presentation.pptx
</commit_message>
<xml_diff>
--- a/CSC382 Project Presentation.pptx
+++ b/CSC382 Project Presentation.pptx
@@ -7,11 +7,14 @@
   <p:sldIdLst>
     <p:sldId id="256" r:id="rId2"/>
     <p:sldId id="258" r:id="rId3"/>
-    <p:sldId id="260" r:id="rId4"/>
-    <p:sldId id="261" r:id="rId5"/>
-    <p:sldId id="259" r:id="rId6"/>
-    <p:sldId id="262" r:id="rId7"/>
-    <p:sldId id="263" r:id="rId8"/>
+    <p:sldId id="266" r:id="rId4"/>
+    <p:sldId id="260" r:id="rId5"/>
+    <p:sldId id="261" r:id="rId6"/>
+    <p:sldId id="264" r:id="rId7"/>
+    <p:sldId id="259" r:id="rId8"/>
+    <p:sldId id="265" r:id="rId9"/>
+    <p:sldId id="262" r:id="rId10"/>
+    <p:sldId id="263" r:id="rId11"/>
   </p:sldIdLst>
   <p:sldSz cx="12192000" cy="6858000"/>
   <p:notesSz cx="6858000" cy="9144000"/>
@@ -110,6 +113,11 @@
       </a:defRPr>
     </a:lvl9pPr>
   </p:defaultTextStyle>
+  <p:extLst>
+    <p:ext uri="{EFAFB233-063F-42B5-8137-9DF3F51BA10A}">
+      <p15:sldGuideLst xmlns:p15="http://schemas.microsoft.com/office/powerpoint/2012/main"/>
+    </p:ext>
+  </p:extLst>
 </p:presentation>
 </file>
 
@@ -276,7 +284,7 @@
           <a:p>
             <a:fld id="{1160EA64-D806-43AC-9DF2-F8C432F32B4C}" type="datetimeFigureOut">
               <a:rPr lang="en-US" dirty="0"/>
-              <a:t>4/15/26</a:t>
+              <a:t>4/16/26</a:t>
             </a:fld>
             <a:endParaRPr lang="en-US" dirty="0"/>
           </a:p>
@@ -442,7 +450,7 @@
           <a:p>
             <a:fld id="{E9F9C37B-1D36-470B-8223-D6C91242EC14}" type="datetimeFigureOut">
               <a:rPr lang="en-US" dirty="0"/>
-              <a:t>4/15/26</a:t>
+              <a:t>4/16/26</a:t>
             </a:fld>
             <a:endParaRPr lang="en-US" dirty="0"/>
           </a:p>
@@ -617,7 +625,7 @@
           <a:p>
             <a:fld id="{67C6F52A-A82B-47A2-A83A-8C4C91F2D59F}" type="datetimeFigureOut">
               <a:rPr lang="en-US" dirty="0"/>
-              <a:t>4/15/26</a:t>
+              <a:t>4/16/26</a:t>
             </a:fld>
             <a:endParaRPr lang="en-US" dirty="0"/>
           </a:p>
@@ -782,7 +790,7 @@
           <a:p>
             <a:fld id="{F070A7B3-6521-4DCA-87E5-044747A908C1}" type="datetimeFigureOut">
               <a:rPr lang="en-US" dirty="0"/>
-              <a:t>4/15/26</a:t>
+              <a:t>4/16/26</a:t>
             </a:fld>
             <a:endParaRPr lang="en-US" dirty="0"/>
           </a:p>
@@ -1046,7 +1054,7 @@
           <a:p>
             <a:fld id="{1160EA64-D806-43AC-9DF2-F8C432F32B4C}" type="datetimeFigureOut">
               <a:rPr lang="en-US" dirty="0"/>
-              <a:t>4/15/26</a:t>
+              <a:t>4/16/26</a:t>
             </a:fld>
             <a:endParaRPr lang="en-US" dirty="0"/>
           </a:p>
@@ -1274,7 +1282,7 @@
           <a:p>
             <a:fld id="{AB134690-1557-4C89-A502-4959FE7FAD70}" type="datetimeFigureOut">
               <a:rPr lang="en-US" dirty="0"/>
-              <a:t>4/15/26</a:t>
+              <a:t>4/16/26</a:t>
             </a:fld>
             <a:endParaRPr lang="en-US" dirty="0"/>
           </a:p>
@@ -1628,7 +1636,7 @@
           <a:p>
             <a:fld id="{4F7D4976-E339-4826-83B7-FBD03F55ECF8}" type="datetimeFigureOut">
               <a:rPr lang="en-US" dirty="0"/>
-              <a:t>4/15/26</a:t>
+              <a:t>4/16/26</a:t>
             </a:fld>
             <a:endParaRPr lang="en-US" dirty="0"/>
           </a:p>
@@ -1764,7 +1772,7 @@
           <a:p>
             <a:fld id="{E1037C31-9E7A-4F99-8774-A0E530DE1A42}" type="datetimeFigureOut">
               <a:rPr lang="en-US" dirty="0"/>
-              <a:t>4/15/26</a:t>
+              <a:t>4/16/26</a:t>
             </a:fld>
             <a:endParaRPr lang="en-US" dirty="0"/>
           </a:p>
@@ -1854,7 +1862,7 @@
           <a:p>
             <a:fld id="{C278504F-A551-4DE0-9316-4DCD1D8CC752}" type="datetimeFigureOut">
               <a:rPr lang="en-US" dirty="0"/>
-              <a:t>4/15/26</a:t>
+              <a:t>4/16/26</a:t>
             </a:fld>
             <a:endParaRPr lang="en-US" dirty="0"/>
           </a:p>
@@ -2213,7 +2221,7 @@
           <a:p>
             <a:fld id="{D1BE4249-C0D0-4B06-8692-E8BB871AF643}" type="datetimeFigureOut">
               <a:rPr lang="en-US" dirty="0"/>
-              <a:t>4/15/26</a:t>
+              <a:t>4/16/26</a:t>
             </a:fld>
             <a:endParaRPr lang="en-US" dirty="0"/>
           </a:p>
@@ -2572,7 +2580,7 @@
           <a:p>
             <a:fld id="{042B0DB6-F5C7-45FB-8CF3-31B45F9C2DAC}" type="datetimeFigureOut">
               <a:rPr lang="en-US" dirty="0"/>
-              <a:t>4/15/26</a:t>
+              <a:t>4/16/26</a:t>
             </a:fld>
             <a:endParaRPr lang="en-US" dirty="0"/>
           </a:p>
@@ -2809,7 +2817,7 @@
           <a:p>
             <a:fld id="{1160EA64-D806-43AC-9DF2-F8C432F32B4C}" type="datetimeFigureOut">
               <a:rPr lang="en-US" dirty="0"/>
-              <a:t>4/15/26</a:t>
+              <a:t>4/16/26</a:t>
             </a:fld>
             <a:endParaRPr lang="en-US" dirty="0"/>
           </a:p>
@@ -3327,6 +3335,94 @@
 </p:sld>
 </file>
 
+<file path=ppt/slides/slide10.xml><?xml version="1.0" encoding="utf-8"?>
+<p:sld xmlns:a="http://schemas.openxmlformats.org/drawingml/2006/main" xmlns:r="http://schemas.openxmlformats.org/officeDocument/2006/relationships" xmlns:p="http://schemas.openxmlformats.org/presentationml/2006/main">
+  <p:cSld>
+    <p:spTree>
+      <p:nvGrpSpPr>
+        <p:cNvPr id="1" name=""/>
+        <p:cNvGrpSpPr/>
+        <p:nvPr/>
+      </p:nvGrpSpPr>
+      <p:grpSpPr>
+        <a:xfrm>
+          <a:off x="0" y="0"/>
+          <a:ext cx="0" cy="0"/>
+          <a:chOff x="0" y="0"/>
+          <a:chExt cx="0" cy="0"/>
+        </a:xfrm>
+      </p:grpSpPr>
+      <p:sp>
+        <p:nvSpPr>
+          <p:cNvPr id="2" name="Title 1">
+            <a:extLst>
+              <a:ext uri="{FF2B5EF4-FFF2-40B4-BE49-F238E27FC236}">
+                <a16:creationId xmlns:a16="http://schemas.microsoft.com/office/drawing/2014/main" id="{E8A141B7-AA3E-1139-FB43-816D6EAD4BE2}"/>
+              </a:ext>
+            </a:extLst>
+          </p:cNvPr>
+          <p:cNvSpPr>
+            <a:spLocks noGrp="1"/>
+          </p:cNvSpPr>
+          <p:nvPr>
+            <p:ph type="ctrTitle"/>
+          </p:nvPr>
+        </p:nvSpPr>
+        <p:spPr/>
+        <p:txBody>
+          <a:bodyPr/>
+          <a:lstStyle/>
+          <a:p>
+            <a:r>
+              <a:rPr lang="en-US" dirty="0"/>
+              <a:t>The End</a:t>
+            </a:r>
+          </a:p>
+        </p:txBody>
+      </p:sp>
+      <p:sp>
+        <p:nvSpPr>
+          <p:cNvPr id="3" name="Subtitle 2">
+            <a:extLst>
+              <a:ext uri="{FF2B5EF4-FFF2-40B4-BE49-F238E27FC236}">
+                <a16:creationId xmlns:a16="http://schemas.microsoft.com/office/drawing/2014/main" id="{1F4AFE92-D14E-18AA-573F-0B64154CCB53}"/>
+              </a:ext>
+            </a:extLst>
+          </p:cNvPr>
+          <p:cNvSpPr>
+            <a:spLocks noGrp="1"/>
+          </p:cNvSpPr>
+          <p:nvPr>
+            <p:ph type="subTitle" idx="1"/>
+          </p:nvPr>
+        </p:nvSpPr>
+        <p:spPr/>
+        <p:txBody>
+          <a:bodyPr>
+            <a:normAutofit/>
+          </a:bodyPr>
+          <a:lstStyle/>
+          <a:p>
+            <a:r>
+              <a:rPr lang="en-US" sz="3200" dirty="0"/>
+              <a:t>Any Questions?</a:t>
+            </a:r>
+          </a:p>
+        </p:txBody>
+      </p:sp>
+    </p:spTree>
+    <p:extLst>
+      <p:ext uri="{BB962C8B-B14F-4D97-AF65-F5344CB8AC3E}">
+        <p14:creationId xmlns:p14="http://schemas.microsoft.com/office/powerpoint/2010/main" val="1889150843"/>
+      </p:ext>
+    </p:extLst>
+  </p:cSld>
+  <p:clrMapOvr>
+    <a:masterClrMapping/>
+  </p:clrMapOvr>
+</p:sld>
+</file>
+
 <file path=ppt/slides/slide2.xml><?xml version="1.0" encoding="utf-8"?>
 <p:sld xmlns:a="http://schemas.openxmlformats.org/drawingml/2006/main" xmlns:r="http://schemas.openxmlformats.org/officeDocument/2006/relationships" xmlns:p="http://schemas.openxmlformats.org/presentationml/2006/main">
   <p:cSld>
@@ -3395,19 +3491,18 @@
           <a:lstStyle/>
           <a:p>
             <a:r>
-              <a:rPr lang="en-US"/>
-              <a:t>Players in soccer have about to be bought and sold going up to tens of millions of dollars.</a:t>
-            </a:r>
-          </a:p>
-          <a:p>
-            <a:endParaRPr lang="en-US"/>
-          </a:p>
-          <a:p>
-            <a:r>
-              <a:rPr lang="en-US"/>
+              <a:rPr lang="en-US" dirty="0"/>
+              <a:t>Players in soccer are bought and sold going up to tens of millions of dollars.</a:t>
+            </a:r>
+          </a:p>
+          <a:p>
+            <a:endParaRPr lang="en-US" dirty="0"/>
+          </a:p>
+          <a:p>
+            <a:r>
+              <a:rPr lang="en-US" dirty="0"/>
               <a:t>Spending the wrong amount on players leads to clubs creating debt and teams with years of history disappearing in obscurity</a:t>
             </a:r>
-            <a:endParaRPr lang="en-US" dirty="0"/>
           </a:p>
         </p:txBody>
       </p:sp>
@@ -3455,6 +3550,131 @@
 </file>
 
 <file path=ppt/slides/slide3.xml><?xml version="1.0" encoding="utf-8"?>
+<p:sld xmlns:a="http://schemas.openxmlformats.org/drawingml/2006/main" xmlns:r="http://schemas.openxmlformats.org/officeDocument/2006/relationships" xmlns:p="http://schemas.openxmlformats.org/presentationml/2006/main">
+  <p:cSld>
+    <p:spTree>
+      <p:nvGrpSpPr>
+        <p:cNvPr id="1" name=""/>
+        <p:cNvGrpSpPr/>
+        <p:nvPr/>
+      </p:nvGrpSpPr>
+      <p:grpSpPr>
+        <a:xfrm>
+          <a:off x="0" y="0"/>
+          <a:ext cx="0" cy="0"/>
+          <a:chOff x="0" y="0"/>
+          <a:chExt cx="0" cy="0"/>
+        </a:xfrm>
+      </p:grpSpPr>
+      <p:sp>
+        <p:nvSpPr>
+          <p:cNvPr id="2" name="Title 1">
+            <a:extLst>
+              <a:ext uri="{FF2B5EF4-FFF2-40B4-BE49-F238E27FC236}">
+                <a16:creationId xmlns:a16="http://schemas.microsoft.com/office/drawing/2014/main" id="{D558577D-3184-7B4E-833D-29474C730217}"/>
+              </a:ext>
+            </a:extLst>
+          </p:cNvPr>
+          <p:cNvSpPr>
+            <a:spLocks noGrp="1"/>
+          </p:cNvSpPr>
+          <p:nvPr>
+            <p:ph type="title"/>
+          </p:nvPr>
+        </p:nvSpPr>
+        <p:spPr/>
+        <p:txBody>
+          <a:bodyPr/>
+          <a:lstStyle/>
+          <a:p>
+            <a:r>
+              <a:rPr lang="en-US" dirty="0"/>
+              <a:t>Problem</a:t>
+            </a:r>
+          </a:p>
+        </p:txBody>
+      </p:sp>
+      <p:sp>
+        <p:nvSpPr>
+          <p:cNvPr id="4" name="Text Placeholder 3">
+            <a:extLst>
+              <a:ext uri="{FF2B5EF4-FFF2-40B4-BE49-F238E27FC236}">
+                <a16:creationId xmlns:a16="http://schemas.microsoft.com/office/drawing/2014/main" id="{DE00C556-FFBE-EB5D-D89C-03C361140132}"/>
+              </a:ext>
+            </a:extLst>
+          </p:cNvPr>
+          <p:cNvSpPr>
+            <a:spLocks noGrp="1"/>
+          </p:cNvSpPr>
+          <p:nvPr>
+            <p:ph type="body" sz="half" idx="2"/>
+          </p:nvPr>
+        </p:nvSpPr>
+        <p:spPr/>
+        <p:txBody>
+          <a:bodyPr/>
+          <a:lstStyle/>
+          <a:p>
+            <a:r>
+              <a:rPr lang="en-US" dirty="0"/>
+              <a:t>Trying to predict the market value of a soccer player at the current point of their career</a:t>
+            </a:r>
+          </a:p>
+          <a:p>
+            <a:endParaRPr lang="en-US" dirty="0"/>
+          </a:p>
+          <a:p>
+            <a:r>
+              <a:rPr lang="en-US" dirty="0"/>
+              <a:t>Transfermarkt has their own values which are not possible to replicate as they use features which are not possible to use in this dataset (injury history, current form, nationality)</a:t>
+            </a:r>
+          </a:p>
+        </p:txBody>
+      </p:sp>
+      <p:pic>
+        <p:nvPicPr>
+          <p:cNvPr id="6" name="Picture 5">
+            <a:extLst>
+              <a:ext uri="{FF2B5EF4-FFF2-40B4-BE49-F238E27FC236}">
+                <a16:creationId xmlns:a16="http://schemas.microsoft.com/office/drawing/2014/main" id="{665061AC-F5CB-7A22-B876-CF085A1F7831}"/>
+              </a:ext>
+            </a:extLst>
+          </p:cNvPr>
+          <p:cNvPicPr>
+            <a:picLocks noChangeAspect="1"/>
+          </p:cNvPicPr>
+          <p:nvPr/>
+        </p:nvPicPr>
+        <p:blipFill>
+          <a:blip r:embed="rId2"/>
+          <a:stretch>
+            <a:fillRect/>
+          </a:stretch>
+        </p:blipFill>
+        <p:spPr>
+          <a:xfrm>
+            <a:off x="6096000" y="1055078"/>
+            <a:ext cx="5960012" cy="4448415"/>
+          </a:xfrm>
+          <a:prstGeom prst="rect">
+            <a:avLst/>
+          </a:prstGeom>
+        </p:spPr>
+      </p:pic>
+    </p:spTree>
+    <p:extLst>
+      <p:ext uri="{BB962C8B-B14F-4D97-AF65-F5344CB8AC3E}">
+        <p14:creationId xmlns:p14="http://schemas.microsoft.com/office/powerpoint/2010/main" val="3724910100"/>
+      </p:ext>
+    </p:extLst>
+  </p:cSld>
+  <p:clrMapOvr>
+    <a:masterClrMapping/>
+  </p:clrMapOvr>
+</p:sld>
+</file>
+
+<file path=ppt/slides/slide4.xml><?xml version="1.0" encoding="utf-8"?>
 <p:sld xmlns:a="http://schemas.openxmlformats.org/drawingml/2006/main" xmlns:r="http://schemas.openxmlformats.org/officeDocument/2006/relationships" xmlns:p="http://schemas.openxmlformats.org/presentationml/2006/main">
   <p:cSld>
     <p:bg>
@@ -3929,215 +4149,6 @@
 </p:sld>
 </file>
 
-<file path=ppt/slides/slide4.xml><?xml version="1.0" encoding="utf-8"?>
-<p:sld xmlns:a="http://schemas.openxmlformats.org/drawingml/2006/main" xmlns:r="http://schemas.openxmlformats.org/officeDocument/2006/relationships" xmlns:p="http://schemas.openxmlformats.org/presentationml/2006/main">
-  <p:cSld>
-    <p:spTree>
-      <p:nvGrpSpPr>
-        <p:cNvPr id="1" name=""/>
-        <p:cNvGrpSpPr/>
-        <p:nvPr/>
-      </p:nvGrpSpPr>
-      <p:grpSpPr>
-        <a:xfrm>
-          <a:off x="0" y="0"/>
-          <a:ext cx="0" cy="0"/>
-          <a:chOff x="0" y="0"/>
-          <a:chExt cx="0" cy="0"/>
-        </a:xfrm>
-      </p:grpSpPr>
-      <p:sp>
-        <p:nvSpPr>
-          <p:cNvPr id="2" name="Title 1">
-            <a:extLst>
-              <a:ext uri="{FF2B5EF4-FFF2-40B4-BE49-F238E27FC236}">
-                <a16:creationId xmlns:a16="http://schemas.microsoft.com/office/drawing/2014/main" id="{CDE8094B-B35C-1A34-F8EF-B3874923E47B}"/>
-              </a:ext>
-            </a:extLst>
-          </p:cNvPr>
-          <p:cNvSpPr>
-            <a:spLocks noGrp="1"/>
-          </p:cNvSpPr>
-          <p:nvPr>
-            <p:ph type="title"/>
-          </p:nvPr>
-        </p:nvSpPr>
-        <p:spPr/>
-        <p:txBody>
-          <a:bodyPr/>
-          <a:lstStyle/>
-          <a:p>
-            <a:r>
-              <a:rPr lang="en-US" dirty="0"/>
-              <a:t>Feature Engineering </a:t>
-            </a:r>
-          </a:p>
-        </p:txBody>
-      </p:sp>
-      <p:sp>
-        <p:nvSpPr>
-          <p:cNvPr id="3" name="Content Placeholder 2">
-            <a:extLst>
-              <a:ext uri="{FF2B5EF4-FFF2-40B4-BE49-F238E27FC236}">
-                <a16:creationId xmlns:a16="http://schemas.microsoft.com/office/drawing/2014/main" id="{A2FF47E4-4893-256B-9F64-10CF477B2E23}"/>
-              </a:ext>
-            </a:extLst>
-          </p:cNvPr>
-          <p:cNvSpPr>
-            <a:spLocks noGrp="1"/>
-          </p:cNvSpPr>
-          <p:nvPr>
-            <p:ph idx="1"/>
-          </p:nvPr>
-        </p:nvSpPr>
-        <p:spPr/>
-        <p:txBody>
-          <a:bodyPr>
-            <a:normAutofit/>
-          </a:bodyPr>
-          <a:lstStyle/>
-          <a:p>
-            <a:pPr marL="0" indent="0" algn="ctr">
-              <a:buNone/>
-            </a:pPr>
-            <a:r>
-              <a:rPr lang="en-US" dirty="0"/>
-              <a:t>Features</a:t>
-            </a:r>
-          </a:p>
-          <a:p>
-            <a:r>
-              <a:rPr lang="en-US" dirty="0"/>
-              <a:t>Position</a:t>
-            </a:r>
-          </a:p>
-          <a:p>
-            <a:r>
-              <a:rPr lang="en-US" dirty="0"/>
-              <a:t>Position</a:t>
-            </a:r>
-          </a:p>
-          <a:p>
-            <a:r>
-              <a:rPr lang="en-US" dirty="0"/>
-              <a:t>Foot</a:t>
-            </a:r>
-          </a:p>
-          <a:p>
-            <a:r>
-              <a:rPr lang="en-US" dirty="0"/>
-              <a:t>Height in cm</a:t>
-            </a:r>
-          </a:p>
-          <a:p>
-            <a:r>
-              <a:rPr lang="en-US" dirty="0"/>
-              <a:t>Age</a:t>
-            </a:r>
-          </a:p>
-          <a:p>
-            <a:r>
-              <a:rPr lang="en-US" dirty="0"/>
-              <a:t>Current Domestic Competition</a:t>
-            </a:r>
-          </a:p>
-          <a:p>
-            <a:r>
-              <a:rPr lang="en-US" dirty="0"/>
-              <a:t>Goals per Game</a:t>
-            </a:r>
-          </a:p>
-          <a:p>
-            <a:r>
-              <a:rPr lang="en-US" dirty="0"/>
-              <a:t>Assists per Game</a:t>
-            </a:r>
-          </a:p>
-          <a:p>
-            <a:r>
-              <a:rPr lang="en-US" dirty="0"/>
-              <a:t>Minutes per Game</a:t>
-            </a:r>
-          </a:p>
-          <a:p>
-            <a:r>
-              <a:rPr lang="en-US" dirty="0"/>
-              <a:t>Yellow cards per Game</a:t>
-            </a:r>
-          </a:p>
-          <a:p>
-            <a:r>
-              <a:rPr lang="en-US" dirty="0"/>
-              <a:t>Total Appearances</a:t>
-            </a:r>
-          </a:p>
-          <a:p>
-            <a:pPr marL="0" indent="0">
-              <a:buNone/>
-            </a:pPr>
-            <a:endParaRPr lang="en-US" dirty="0"/>
-          </a:p>
-          <a:p>
-            <a:endParaRPr lang="en-US" dirty="0"/>
-          </a:p>
-          <a:p>
-            <a:endParaRPr lang="en-US" dirty="0"/>
-          </a:p>
-        </p:txBody>
-      </p:sp>
-      <p:sp>
-        <p:nvSpPr>
-          <p:cNvPr id="4" name="Text Placeholder 3">
-            <a:extLst>
-              <a:ext uri="{FF2B5EF4-FFF2-40B4-BE49-F238E27FC236}">
-                <a16:creationId xmlns:a16="http://schemas.microsoft.com/office/drawing/2014/main" id="{D493C6A5-BFA3-01ED-06F4-3BF126E3896E}"/>
-              </a:ext>
-            </a:extLst>
-          </p:cNvPr>
-          <p:cNvSpPr>
-            <a:spLocks noGrp="1"/>
-          </p:cNvSpPr>
-          <p:nvPr>
-            <p:ph type="body" sz="half" idx="2"/>
-          </p:nvPr>
-        </p:nvSpPr>
-        <p:spPr/>
-        <p:txBody>
-          <a:bodyPr/>
-          <a:lstStyle/>
-          <a:p>
-            <a:r>
-              <a:rPr lang="en-US" dirty="0"/>
-              <a:t>Combined all datasets into one main dataset</a:t>
-            </a:r>
-          </a:p>
-          <a:p>
-            <a:r>
-              <a:rPr lang="en-US" dirty="0"/>
-              <a:t>One Hot Encoding for all categorical values</a:t>
-            </a:r>
-          </a:p>
-          <a:p>
-            <a:r>
-              <a:rPr lang="en-US" dirty="0"/>
-              <a:t>Condensed the features into 11 features to predict market value</a:t>
-            </a:r>
-          </a:p>
-        </p:txBody>
-      </p:sp>
-    </p:spTree>
-    <p:extLst>
-      <p:ext uri="{BB962C8B-B14F-4D97-AF65-F5344CB8AC3E}">
-        <p14:creationId xmlns:p14="http://schemas.microsoft.com/office/powerpoint/2010/main" val="2199489924"/>
-      </p:ext>
-    </p:extLst>
-  </p:cSld>
-  <p:clrMapOvr>
-    <a:masterClrMapping/>
-  </p:clrMapOvr>
-</p:sld>
-</file>
-
 <file path=ppt/slides/slide5.xml><?xml version="1.0" encoding="utf-8"?>
 <p:sld xmlns:a="http://schemas.openxmlformats.org/drawingml/2006/main" xmlns:r="http://schemas.openxmlformats.org/officeDocument/2006/relationships" xmlns:p="http://schemas.openxmlformats.org/presentationml/2006/main">
   <p:cSld>
@@ -4160,7 +4171,7 @@
           <p:cNvPr id="2" name="Title 1">
             <a:extLst>
               <a:ext uri="{FF2B5EF4-FFF2-40B4-BE49-F238E27FC236}">
-                <a16:creationId xmlns:a16="http://schemas.microsoft.com/office/drawing/2014/main" id="{539C3C95-044A-1504-C0AC-95662A05CFB5}"/>
+                <a16:creationId xmlns:a16="http://schemas.microsoft.com/office/drawing/2014/main" id="{CDE8094B-B35C-1A34-F8EF-B3874923E47B}"/>
               </a:ext>
             </a:extLst>
           </p:cNvPr>
@@ -4178,7 +4189,7 @@
           <a:p>
             <a:r>
               <a:rPr lang="en-US" dirty="0"/>
-              <a:t>Models</a:t>
+              <a:t>Feature Engineering </a:t>
             </a:r>
           </a:p>
         </p:txBody>
@@ -4188,7 +4199,7 @@
           <p:cNvPr id="3" name="Content Placeholder 2">
             <a:extLst>
               <a:ext uri="{FF2B5EF4-FFF2-40B4-BE49-F238E27FC236}">
-                <a16:creationId xmlns:a16="http://schemas.microsoft.com/office/drawing/2014/main" id="{C84338B8-D0A0-EDEF-570B-411CA3AAC7CB}"/>
+                <a16:creationId xmlns:a16="http://schemas.microsoft.com/office/drawing/2014/main" id="{A2FF47E4-4893-256B-9F64-10CF477B2E23}"/>
               </a:ext>
             </a:extLst>
           </p:cNvPr>
@@ -4199,14 +4210,11 @@
             <p:ph idx="1"/>
           </p:nvPr>
         </p:nvSpPr>
-        <p:spPr>
-          <a:xfrm>
-            <a:off x="854516" y="3153597"/>
-            <a:ext cx="2753240" cy="3101983"/>
-          </a:xfrm>
-        </p:spPr>
-        <p:txBody>
-          <a:bodyPr/>
+        <p:spPr/>
+        <p:txBody>
+          <a:bodyPr>
+            <a:normAutofit/>
+          </a:bodyPr>
           <a:lstStyle/>
           <a:p>
             <a:pPr marL="0" indent="0" algn="ctr">
@@ -4214,124 +4222,125 @@
             </a:pPr>
             <a:r>
               <a:rPr lang="en-US" dirty="0"/>
-              <a:t>Baseline Model</a:t>
-            </a:r>
-          </a:p>
-          <a:p>
-            <a:pPr marL="0" indent="0" algn="ctr">
+              <a:t>Features</a:t>
+            </a:r>
+          </a:p>
+          <a:p>
+            <a:r>
+              <a:rPr lang="en-US" dirty="0"/>
+              <a:t>Position</a:t>
+            </a:r>
+          </a:p>
+          <a:p>
+            <a:r>
+              <a:rPr lang="en-US" dirty="0"/>
+              <a:t>Sub Position</a:t>
+            </a:r>
+          </a:p>
+          <a:p>
+            <a:r>
+              <a:rPr lang="en-US" dirty="0"/>
+              <a:t>Foot</a:t>
+            </a:r>
+          </a:p>
+          <a:p>
+            <a:r>
+              <a:rPr lang="en-US" dirty="0"/>
+              <a:t>Height in cm</a:t>
+            </a:r>
+          </a:p>
+          <a:p>
+            <a:r>
+              <a:rPr lang="en-US" dirty="0"/>
+              <a:t>Age</a:t>
+            </a:r>
+          </a:p>
+          <a:p>
+            <a:r>
+              <a:rPr lang="en-US" dirty="0"/>
+              <a:t>Current Domestic Competition</a:t>
+            </a:r>
+          </a:p>
+          <a:p>
+            <a:r>
+              <a:rPr lang="en-US" dirty="0"/>
+              <a:t>Goals per Game</a:t>
+            </a:r>
+          </a:p>
+          <a:p>
+            <a:r>
+              <a:rPr lang="en-US" dirty="0"/>
+              <a:t>Assists per Game</a:t>
+            </a:r>
+          </a:p>
+          <a:p>
+            <a:r>
+              <a:rPr lang="en-US" dirty="0"/>
+              <a:t>Minutes per Game</a:t>
+            </a:r>
+          </a:p>
+          <a:p>
+            <a:r>
+              <a:rPr lang="en-US" dirty="0"/>
+              <a:t>Yellow cards per Game</a:t>
+            </a:r>
+          </a:p>
+          <a:p>
+            <a:r>
+              <a:rPr lang="en-US" dirty="0"/>
+              <a:t>Total Appearances</a:t>
+            </a:r>
+          </a:p>
+          <a:p>
+            <a:pPr marL="0" indent="0">
               <a:buNone/>
             </a:pPr>
             <a:endParaRPr lang="en-US" dirty="0"/>
           </a:p>
           <a:p>
-            <a:pPr marL="0" indent="0" algn="ctr">
-              <a:buNone/>
-            </a:pPr>
-            <a:r>
-              <a:rPr lang="en-US" dirty="0"/>
-              <a:t>Simple model finding the average mean market values of players in the dataset</a:t>
-            </a:r>
-          </a:p>
-        </p:txBody>
-      </p:sp>
-      <p:sp>
-        <p:nvSpPr>
-          <p:cNvPr id="4" name="TextBox 3">
+            <a:endParaRPr lang="en-US" dirty="0"/>
+          </a:p>
+          <a:p>
+            <a:endParaRPr lang="en-US" dirty="0"/>
+          </a:p>
+        </p:txBody>
+      </p:sp>
+      <p:sp>
+        <p:nvSpPr>
+          <p:cNvPr id="4" name="Text Placeholder 3">
             <a:extLst>
               <a:ext uri="{FF2B5EF4-FFF2-40B4-BE49-F238E27FC236}">
-                <a16:creationId xmlns:a16="http://schemas.microsoft.com/office/drawing/2014/main" id="{8381CE78-FAE6-853E-7DFE-189789B23BC3}"/>
+                <a16:creationId xmlns:a16="http://schemas.microsoft.com/office/drawing/2014/main" id="{D493C6A5-BFA3-01ED-06F4-3BF126E3896E}"/>
               </a:ext>
             </a:extLst>
           </p:cNvPr>
-          <p:cNvSpPr txBox="1"/>
-          <p:nvPr/>
-        </p:nvSpPr>
-        <p:spPr>
-          <a:xfrm>
-            <a:off x="4719380" y="3153597"/>
-            <a:ext cx="2753240" cy="2308324"/>
-          </a:xfrm>
-          <a:prstGeom prst="rect">
-            <a:avLst/>
-          </a:prstGeom>
-          <a:noFill/>
-        </p:spPr>
-        <p:txBody>
-          <a:bodyPr wrap="square" rtlCol="0">
-            <a:spAutoFit/>
-          </a:bodyPr>
-          <a:lstStyle/>
-          <a:p>
-            <a:pPr algn="ctr"/>
-            <a:r>
-              <a:rPr lang="en-US" dirty="0"/>
-              <a:t>Linear Regression</a:t>
-            </a:r>
-          </a:p>
-          <a:p>
-            <a:pPr algn="ctr"/>
-            <a:endParaRPr lang="en-US" dirty="0"/>
-          </a:p>
-          <a:p>
-            <a:pPr algn="ctr"/>
-            <a:endParaRPr lang="en-US" dirty="0"/>
-          </a:p>
-          <a:p>
-            <a:pPr algn="ctr"/>
-            <a:r>
-              <a:rPr lang="en-US" dirty="0"/>
-              <a:t>This model is used to assume the features being used have a linear relationship to try and predict the market value</a:t>
-            </a:r>
-          </a:p>
-        </p:txBody>
-      </p:sp>
-      <p:sp>
-        <p:nvSpPr>
-          <p:cNvPr id="5" name="TextBox 4">
-            <a:extLst>
-              <a:ext uri="{FF2B5EF4-FFF2-40B4-BE49-F238E27FC236}">
-                <a16:creationId xmlns:a16="http://schemas.microsoft.com/office/drawing/2014/main" id="{621F9A1D-4D97-27FE-9B37-4F3CA31B190E}"/>
-              </a:ext>
-            </a:extLst>
-          </p:cNvPr>
-          <p:cNvSpPr txBox="1"/>
-          <p:nvPr/>
-        </p:nvSpPr>
-        <p:spPr>
-          <a:xfrm>
-            <a:off x="8584244" y="3153597"/>
-            <a:ext cx="2753240" cy="1200329"/>
-          </a:xfrm>
-          <a:prstGeom prst="rect">
-            <a:avLst/>
-          </a:prstGeom>
-          <a:noFill/>
-        </p:spPr>
-        <p:txBody>
-          <a:bodyPr wrap="square" rtlCol="0">
-            <a:spAutoFit/>
-          </a:bodyPr>
-          <a:lstStyle/>
-          <a:p>
-            <a:pPr algn="ctr"/>
-            <a:r>
-              <a:rPr lang="en-US" dirty="0"/>
-              <a:t>Decision Tree</a:t>
-            </a:r>
-          </a:p>
-          <a:p>
-            <a:pPr algn="ctr"/>
-            <a:endParaRPr lang="en-US" dirty="0"/>
-          </a:p>
-          <a:p>
-            <a:pPr algn="ctr"/>
-            <a:endParaRPr lang="en-US" dirty="0"/>
-          </a:p>
-          <a:p>
-            <a:pPr algn="ctr"/>
-            <a:r>
-              <a:rPr lang="en-US" dirty="0"/>
-              <a:t>This model is being used as </a:t>
+          <p:cNvSpPr>
+            <a:spLocks noGrp="1"/>
+          </p:cNvSpPr>
+          <p:nvPr>
+            <p:ph type="body" sz="half" idx="2"/>
+          </p:nvPr>
+        </p:nvSpPr>
+        <p:spPr/>
+        <p:txBody>
+          <a:bodyPr/>
+          <a:lstStyle/>
+          <a:p>
+            <a:r>
+              <a:rPr lang="en-US" dirty="0"/>
+              <a:t>Combined all datasets into one main dataset</a:t>
+            </a:r>
+          </a:p>
+          <a:p>
+            <a:r>
+              <a:rPr lang="en-US" dirty="0"/>
+              <a:t>One Hot Encoding for all categorical values</a:t>
+            </a:r>
+          </a:p>
+          <a:p>
+            <a:r>
+              <a:rPr lang="en-US" dirty="0"/>
+              <a:t>Condensed the features into 11 features to predict market value</a:t>
             </a:r>
           </a:p>
         </p:txBody>
@@ -4339,7 +4348,7 @@
     </p:spTree>
     <p:extLst>
       <p:ext uri="{BB962C8B-B14F-4D97-AF65-F5344CB8AC3E}">
-        <p14:creationId xmlns:p14="http://schemas.microsoft.com/office/powerpoint/2010/main" val="629720946"/>
+        <p14:creationId xmlns:p14="http://schemas.microsoft.com/office/powerpoint/2010/main" val="2199489924"/>
       </p:ext>
     </p:extLst>
   </p:cSld>
@@ -4371,7 +4380,7 @@
           <p:cNvPr id="2" name="Title 1">
             <a:extLst>
               <a:ext uri="{FF2B5EF4-FFF2-40B4-BE49-F238E27FC236}">
-                <a16:creationId xmlns:a16="http://schemas.microsoft.com/office/drawing/2014/main" id="{C4B9F71C-6E14-327E-49DC-2DDD3B3C1C42}"/>
+                <a16:creationId xmlns:a16="http://schemas.microsoft.com/office/drawing/2014/main" id="{84B26AEC-D8A1-E8D9-994B-9814FE03D81A}"/>
               </a:ext>
             </a:extLst>
           </p:cNvPr>
@@ -4389,58 +4398,45 @@
           <a:p>
             <a:r>
               <a:rPr lang="en-US" dirty="0"/>
-              <a:t>Next Steps</a:t>
-            </a:r>
-          </a:p>
-        </p:txBody>
-      </p:sp>
-      <p:sp>
-        <p:nvSpPr>
-          <p:cNvPr id="3" name="Content Placeholder 2">
+              <a:t>Completed Dataset</a:t>
+            </a:r>
+          </a:p>
+        </p:txBody>
+      </p:sp>
+      <p:pic>
+        <p:nvPicPr>
+          <p:cNvPr id="5" name="Picture 4">
             <a:extLst>
               <a:ext uri="{FF2B5EF4-FFF2-40B4-BE49-F238E27FC236}">
-                <a16:creationId xmlns:a16="http://schemas.microsoft.com/office/drawing/2014/main" id="{E242FE87-03C0-CFB9-CB5D-5189616B1C34}"/>
+                <a16:creationId xmlns:a16="http://schemas.microsoft.com/office/drawing/2014/main" id="{33298C1A-F4D6-D747-FE62-7B9C2DC83887}"/>
               </a:ext>
             </a:extLst>
           </p:cNvPr>
-          <p:cNvSpPr>
-            <a:spLocks noGrp="1"/>
-          </p:cNvSpPr>
-          <p:nvPr>
-            <p:ph idx="1"/>
-          </p:nvPr>
-        </p:nvSpPr>
-        <p:spPr/>
-        <p:txBody>
-          <a:bodyPr/>
-          <a:lstStyle/>
-          <a:p>
-            <a:r>
-              <a:rPr lang="en-US" dirty="0"/>
-              <a:t>Finish the remaining models</a:t>
-            </a:r>
-          </a:p>
-          <a:p>
-            <a:r>
-              <a:rPr lang="en-US" dirty="0"/>
-              <a:t>Test all 3 models after adjusting for skewness</a:t>
-            </a:r>
-          </a:p>
-          <a:p>
-            <a:r>
-              <a:rPr lang="en-US" dirty="0"/>
-              <a:t>Adding more features to improve the accuracy score </a:t>
-            </a:r>
-          </a:p>
-          <a:p>
-            <a:endParaRPr lang="en-US" dirty="0"/>
-          </a:p>
-        </p:txBody>
-      </p:sp>
+          <p:cNvPicPr>
+            <a:picLocks noChangeAspect="1"/>
+          </p:cNvPicPr>
+          <p:nvPr/>
+        </p:nvPicPr>
+        <p:blipFill>
+          <a:blip r:embed="rId2"/>
+          <a:stretch>
+            <a:fillRect/>
+          </a:stretch>
+        </p:blipFill>
+        <p:spPr>
+          <a:xfrm>
+            <a:off x="2209800" y="2153412"/>
+            <a:ext cx="7772400" cy="4504355"/>
+          </a:xfrm>
+          <a:prstGeom prst="rect">
+            <a:avLst/>
+          </a:prstGeom>
+        </p:spPr>
+      </p:pic>
     </p:spTree>
     <p:extLst>
       <p:ext uri="{BB962C8B-B14F-4D97-AF65-F5344CB8AC3E}">
-        <p14:creationId xmlns:p14="http://schemas.microsoft.com/office/powerpoint/2010/main" val="2083120843"/>
+        <p14:creationId xmlns:p14="http://schemas.microsoft.com/office/powerpoint/2010/main" val="2420169304"/>
       </p:ext>
     </p:extLst>
   </p:cSld>
@@ -4472,7 +4468,7 @@
           <p:cNvPr id="2" name="Title 1">
             <a:extLst>
               <a:ext uri="{FF2B5EF4-FFF2-40B4-BE49-F238E27FC236}">
-                <a16:creationId xmlns:a16="http://schemas.microsoft.com/office/drawing/2014/main" id="{E8A141B7-AA3E-1139-FB43-816D6EAD4BE2}"/>
+                <a16:creationId xmlns:a16="http://schemas.microsoft.com/office/drawing/2014/main" id="{539C3C95-044A-1504-C0AC-95662A05CFB5}"/>
               </a:ext>
             </a:extLst>
           </p:cNvPr>
@@ -4480,27 +4476,27 @@
             <a:spLocks noGrp="1"/>
           </p:cNvSpPr>
           <p:nvPr>
-            <p:ph type="ctrTitle"/>
-          </p:nvPr>
-        </p:nvSpPr>
-        <p:spPr/>
-        <p:txBody>
-          <a:bodyPr/>
-          <a:lstStyle/>
-          <a:p>
-            <a:r>
-              <a:rPr lang="en-US" dirty="0"/>
-              <a:t>The End</a:t>
-            </a:r>
-          </a:p>
-        </p:txBody>
-      </p:sp>
-      <p:sp>
-        <p:nvSpPr>
-          <p:cNvPr id="3" name="Subtitle 2">
+            <p:ph type="title"/>
+          </p:nvPr>
+        </p:nvSpPr>
+        <p:spPr/>
+        <p:txBody>
+          <a:bodyPr/>
+          <a:lstStyle/>
+          <a:p>
+            <a:r>
+              <a:rPr lang="en-US" dirty="0"/>
+              <a:t>Models</a:t>
+            </a:r>
+          </a:p>
+        </p:txBody>
+      </p:sp>
+      <p:sp>
+        <p:nvSpPr>
+          <p:cNvPr id="3" name="Content Placeholder 2">
             <a:extLst>
               <a:ext uri="{FF2B5EF4-FFF2-40B4-BE49-F238E27FC236}">
-                <a16:creationId xmlns:a16="http://schemas.microsoft.com/office/drawing/2014/main" id="{1F4AFE92-D14E-18AA-573F-0B64154CCB53}"/>
+                <a16:creationId xmlns:a16="http://schemas.microsoft.com/office/drawing/2014/main" id="{C84338B8-D0A0-EDEF-570B-411CA3AAC7CB}"/>
               </a:ext>
             </a:extLst>
           </p:cNvPr>
@@ -4508,19 +4504,149 @@
             <a:spLocks noGrp="1"/>
           </p:cNvSpPr>
           <p:nvPr>
-            <p:ph type="subTitle" idx="1"/>
-          </p:nvPr>
-        </p:nvSpPr>
-        <p:spPr/>
-        <p:txBody>
-          <a:bodyPr>
-            <a:normAutofit/>
+            <p:ph idx="1"/>
+          </p:nvPr>
+        </p:nvSpPr>
+        <p:spPr>
+          <a:xfrm>
+            <a:off x="854516" y="3153597"/>
+            <a:ext cx="2753240" cy="3101983"/>
+          </a:xfrm>
+        </p:spPr>
+        <p:txBody>
+          <a:bodyPr/>
+          <a:lstStyle/>
+          <a:p>
+            <a:pPr marL="0" indent="0" algn="ctr">
+              <a:buNone/>
+            </a:pPr>
+            <a:r>
+              <a:rPr lang="en-US" dirty="0"/>
+              <a:t>Baseline Model</a:t>
+            </a:r>
+          </a:p>
+          <a:p>
+            <a:pPr marL="0" indent="0" algn="ctr">
+              <a:buNone/>
+            </a:pPr>
+            <a:endParaRPr lang="en-US" dirty="0"/>
+          </a:p>
+          <a:p>
+            <a:pPr marL="0" indent="0" algn="ctr">
+              <a:buNone/>
+            </a:pPr>
+            <a:r>
+              <a:rPr lang="en-US" dirty="0"/>
+              <a:t>Predicts the mean market value for all players (benchmark for future comparisons)</a:t>
+            </a:r>
+          </a:p>
+        </p:txBody>
+      </p:sp>
+      <p:sp>
+        <p:nvSpPr>
+          <p:cNvPr id="4" name="TextBox 3">
+            <a:extLst>
+              <a:ext uri="{FF2B5EF4-FFF2-40B4-BE49-F238E27FC236}">
+                <a16:creationId xmlns:a16="http://schemas.microsoft.com/office/drawing/2014/main" id="{8381CE78-FAE6-853E-7DFE-189789B23BC3}"/>
+              </a:ext>
+            </a:extLst>
+          </p:cNvPr>
+          <p:cNvSpPr txBox="1"/>
+          <p:nvPr/>
+        </p:nvSpPr>
+        <p:spPr>
+          <a:xfrm>
+            <a:off x="4719380" y="3153597"/>
+            <a:ext cx="2753240" cy="2308324"/>
+          </a:xfrm>
+          <a:prstGeom prst="rect">
+            <a:avLst/>
+          </a:prstGeom>
+          <a:noFill/>
+        </p:spPr>
+        <p:txBody>
+          <a:bodyPr wrap="square" rtlCol="0">
+            <a:spAutoFit/>
           </a:bodyPr>
           <a:lstStyle/>
           <a:p>
-            <a:r>
-              <a:rPr lang="en-US" sz="3200" dirty="0"/>
-              <a:t>Any Questions?</a:t>
+            <a:pPr algn="ctr"/>
+            <a:r>
+              <a:rPr lang="en-US" dirty="0"/>
+              <a:t>Linear Regression</a:t>
+            </a:r>
+          </a:p>
+          <a:p>
+            <a:pPr algn="ctr"/>
+            <a:endParaRPr lang="en-US" dirty="0"/>
+          </a:p>
+          <a:p>
+            <a:pPr algn="ctr"/>
+            <a:endParaRPr lang="en-US" dirty="0"/>
+          </a:p>
+          <a:p>
+            <a:pPr algn="ctr"/>
+            <a:r>
+              <a:rPr lang="en-US" dirty="0"/>
+              <a:t>This model is used to assume the features being used have a linear relationship to try and predict the market value</a:t>
+            </a:r>
+          </a:p>
+        </p:txBody>
+      </p:sp>
+      <p:sp>
+        <p:nvSpPr>
+          <p:cNvPr id="5" name="TextBox 4">
+            <a:extLst>
+              <a:ext uri="{FF2B5EF4-FFF2-40B4-BE49-F238E27FC236}">
+                <a16:creationId xmlns:a16="http://schemas.microsoft.com/office/drawing/2014/main" id="{621F9A1D-4D97-27FE-9B37-4F3CA31B190E}"/>
+              </a:ext>
+            </a:extLst>
+          </p:cNvPr>
+          <p:cNvSpPr txBox="1"/>
+          <p:nvPr/>
+        </p:nvSpPr>
+        <p:spPr>
+          <a:xfrm>
+            <a:off x="8584244" y="3153597"/>
+            <a:ext cx="2753240" cy="3139321"/>
+          </a:xfrm>
+          <a:prstGeom prst="rect">
+            <a:avLst/>
+          </a:prstGeom>
+          <a:noFill/>
+        </p:spPr>
+        <p:txBody>
+          <a:bodyPr wrap="square" rtlCol="0">
+            <a:spAutoFit/>
+          </a:bodyPr>
+          <a:lstStyle/>
+          <a:p>
+            <a:pPr algn="ctr"/>
+            <a:r>
+              <a:rPr lang="en-US" dirty="0"/>
+              <a:t>Decision Tree</a:t>
+            </a:r>
+          </a:p>
+          <a:p>
+            <a:pPr algn="ctr"/>
+            <a:endParaRPr lang="en-US" dirty="0"/>
+          </a:p>
+          <a:p>
+            <a:pPr algn="ctr"/>
+            <a:endParaRPr lang="en-US" dirty="0"/>
+          </a:p>
+          <a:p>
+            <a:pPr algn="ctr"/>
+            <a:r>
+              <a:rPr lang="en-US" dirty="0"/>
+              <a:t>Captures nonlinear relationships between player features and market value and can model complex interactions between variables</a:t>
+            </a:r>
+            <a:br>
+              <a:rPr lang="en-US" dirty="0"/>
+            </a:br>
+            <a:r>
+              <a:rPr lang="en-US" dirty="0"/>
+              <a:t>Being used for nonlinear assumptions</a:t>
             </a:r>
           </a:p>
         </p:txBody>
@@ -4528,7 +4654,334 @@
     </p:spTree>
     <p:extLst>
       <p:ext uri="{BB962C8B-B14F-4D97-AF65-F5344CB8AC3E}">
-        <p14:creationId xmlns:p14="http://schemas.microsoft.com/office/powerpoint/2010/main" val="1889150843"/>
+        <p14:creationId xmlns:p14="http://schemas.microsoft.com/office/powerpoint/2010/main" val="629720946"/>
+      </p:ext>
+    </p:extLst>
+  </p:cSld>
+  <p:clrMapOvr>
+    <a:masterClrMapping/>
+  </p:clrMapOvr>
+</p:sld>
+</file>
+
+<file path=ppt/slides/slide8.xml><?xml version="1.0" encoding="utf-8"?>
+<p:sld xmlns:a="http://schemas.openxmlformats.org/drawingml/2006/main" xmlns:r="http://schemas.openxmlformats.org/officeDocument/2006/relationships" xmlns:p="http://schemas.openxmlformats.org/presentationml/2006/main">
+  <p:cSld>
+    <p:spTree>
+      <p:nvGrpSpPr>
+        <p:cNvPr id="1" name=""/>
+        <p:cNvGrpSpPr/>
+        <p:nvPr/>
+      </p:nvGrpSpPr>
+      <p:grpSpPr>
+        <a:xfrm>
+          <a:off x="0" y="0"/>
+          <a:ext cx="0" cy="0"/>
+          <a:chOff x="0" y="0"/>
+          <a:chExt cx="0" cy="0"/>
+        </a:xfrm>
+      </p:grpSpPr>
+      <p:sp>
+        <p:nvSpPr>
+          <p:cNvPr id="2" name="Title 1">
+            <a:extLst>
+              <a:ext uri="{FF2B5EF4-FFF2-40B4-BE49-F238E27FC236}">
+                <a16:creationId xmlns:a16="http://schemas.microsoft.com/office/drawing/2014/main" id="{19ECAACC-AAD1-EB24-7298-4B8D5FA44441}"/>
+              </a:ext>
+            </a:extLst>
+          </p:cNvPr>
+          <p:cNvSpPr>
+            <a:spLocks noGrp="1"/>
+          </p:cNvSpPr>
+          <p:nvPr>
+            <p:ph type="title"/>
+          </p:nvPr>
+        </p:nvSpPr>
+        <p:spPr/>
+        <p:txBody>
+          <a:bodyPr/>
+          <a:lstStyle/>
+          <a:p>
+            <a:r>
+              <a:rPr lang="en-US" dirty="0"/>
+              <a:t>Evaluation metrics</a:t>
+            </a:r>
+          </a:p>
+        </p:txBody>
+      </p:sp>
+      <p:sp>
+        <p:nvSpPr>
+          <p:cNvPr id="3" name="Content Placeholder 2">
+            <a:extLst>
+              <a:ext uri="{FF2B5EF4-FFF2-40B4-BE49-F238E27FC236}">
+                <a16:creationId xmlns:a16="http://schemas.microsoft.com/office/drawing/2014/main" id="{B7FD12AC-FF17-A1B3-1677-290D40277F8B}"/>
+              </a:ext>
+            </a:extLst>
+          </p:cNvPr>
+          <p:cNvSpPr>
+            <a:spLocks noGrp="1"/>
+          </p:cNvSpPr>
+          <p:nvPr>
+            <p:ph sz="half" idx="1"/>
+          </p:nvPr>
+        </p:nvSpPr>
+        <p:spPr/>
+        <p:txBody>
+          <a:bodyPr/>
+          <a:lstStyle/>
+          <a:p>
+            <a:r>
+              <a:rPr lang="en-US" sz="2800" dirty="0"/>
+              <a:t>Mean Squared Error</a:t>
+            </a:r>
+          </a:p>
+          <a:p>
+            <a:r>
+              <a:rPr lang="en-US" sz="2800" dirty="0"/>
+              <a:t>Root Mean Squared Error</a:t>
+            </a:r>
+          </a:p>
+          <a:p>
+            <a:r>
+              <a:rPr lang="en-US" sz="2800" dirty="0"/>
+              <a:t>R</a:t>
+            </a:r>
+            <a:r>
+              <a:rPr lang="en-US" sz="2800" baseline="30000" dirty="0"/>
+              <a:t>2</a:t>
+            </a:r>
+            <a:r>
+              <a:rPr lang="en-US" sz="2800" dirty="0"/>
+              <a:t> Score</a:t>
+            </a:r>
+          </a:p>
+          <a:p>
+            <a:endParaRPr lang="en-US" dirty="0"/>
+          </a:p>
+        </p:txBody>
+      </p:sp>
+      <p:sp>
+        <p:nvSpPr>
+          <p:cNvPr id="4" name="Content Placeholder 3">
+            <a:extLst>
+              <a:ext uri="{FF2B5EF4-FFF2-40B4-BE49-F238E27FC236}">
+                <a16:creationId xmlns:a16="http://schemas.microsoft.com/office/drawing/2014/main" id="{480C930D-AA05-B4CC-D10E-00517B8D4BD3}"/>
+              </a:ext>
+            </a:extLst>
+          </p:cNvPr>
+          <p:cNvSpPr>
+            <a:spLocks noGrp="1"/>
+          </p:cNvSpPr>
+          <p:nvPr>
+            <p:ph sz="half" idx="2"/>
+          </p:nvPr>
+        </p:nvSpPr>
+        <p:spPr/>
+        <p:txBody>
+          <a:bodyPr/>
+          <a:lstStyle/>
+          <a:p>
+            <a:pPr marL="0" indent="0" algn="ctr">
+              <a:buNone/>
+            </a:pPr>
+            <a:r>
+              <a:rPr lang="en-US" dirty="0"/>
+              <a:t>Baseline Model Metrics</a:t>
+            </a:r>
+          </a:p>
+          <a:p>
+            <a:pPr marL="0" indent="0" algn="ctr">
+              <a:buNone/>
+            </a:pPr>
+            <a:r>
+              <a:rPr lang="en-US" dirty="0"/>
+              <a:t>Mean Value: $2,012,081</a:t>
+            </a:r>
+          </a:p>
+          <a:p>
+            <a:pPr marL="0" indent="0" algn="ctr">
+              <a:buNone/>
+            </a:pPr>
+            <a:r>
+              <a:rPr lang="en-US" dirty="0"/>
+              <a:t>MSE: $59052972352271.73</a:t>
+            </a:r>
+          </a:p>
+          <a:p>
+            <a:pPr marL="0" indent="0" algn="ctr">
+              <a:buNone/>
+            </a:pPr>
+            <a:r>
+              <a:rPr lang="en-US" dirty="0"/>
+              <a:t>RMSE: $7,684,593.18</a:t>
+            </a:r>
+          </a:p>
+          <a:p>
+            <a:pPr marL="0" indent="0" algn="ctr">
+              <a:buNone/>
+            </a:pPr>
+            <a:r>
+              <a:rPr lang="en-US" dirty="0"/>
+              <a:t>R</a:t>
+            </a:r>
+            <a:r>
+              <a:rPr lang="en-US" baseline="30000" dirty="0"/>
+              <a:t>2</a:t>
+            </a:r>
+            <a:r>
+              <a:rPr lang="en-US" dirty="0"/>
+              <a:t>: 0.0000</a:t>
+            </a:r>
+          </a:p>
+          <a:p>
+            <a:pPr marL="0" indent="0" algn="ctr">
+              <a:buNone/>
+            </a:pPr>
+            <a:endParaRPr lang="en-US" dirty="0"/>
+          </a:p>
+          <a:p>
+            <a:pPr marL="0" indent="0" algn="ctr">
+              <a:buNone/>
+            </a:pPr>
+            <a:endParaRPr lang="en-US" dirty="0"/>
+          </a:p>
+        </p:txBody>
+      </p:sp>
+      <p:pic>
+        <p:nvPicPr>
+          <p:cNvPr id="6" name="Picture 5">
+            <a:extLst>
+              <a:ext uri="{FF2B5EF4-FFF2-40B4-BE49-F238E27FC236}">
+                <a16:creationId xmlns:a16="http://schemas.microsoft.com/office/drawing/2014/main" id="{95193682-49B4-161D-B237-0C85D39660DA}"/>
+              </a:ext>
+            </a:extLst>
+          </p:cNvPr>
+          <p:cNvPicPr>
+            <a:picLocks noChangeAspect="1"/>
+          </p:cNvPicPr>
+          <p:nvPr/>
+        </p:nvPicPr>
+        <p:blipFill>
+          <a:blip r:embed="rId2"/>
+          <a:stretch>
+            <a:fillRect/>
+          </a:stretch>
+        </p:blipFill>
+        <p:spPr>
+          <a:xfrm>
+            <a:off x="6396422" y="5088632"/>
+            <a:ext cx="4270247" cy="1302787"/>
+          </a:xfrm>
+          <a:prstGeom prst="rect">
+            <a:avLst/>
+          </a:prstGeom>
+        </p:spPr>
+      </p:pic>
+    </p:spTree>
+    <p:extLst>
+      <p:ext uri="{BB962C8B-B14F-4D97-AF65-F5344CB8AC3E}">
+        <p14:creationId xmlns:p14="http://schemas.microsoft.com/office/powerpoint/2010/main" val="264224054"/>
+      </p:ext>
+    </p:extLst>
+  </p:cSld>
+  <p:clrMapOvr>
+    <a:masterClrMapping/>
+  </p:clrMapOvr>
+</p:sld>
+</file>
+
+<file path=ppt/slides/slide9.xml><?xml version="1.0" encoding="utf-8"?>
+<p:sld xmlns:a="http://schemas.openxmlformats.org/drawingml/2006/main" xmlns:r="http://schemas.openxmlformats.org/officeDocument/2006/relationships" xmlns:p="http://schemas.openxmlformats.org/presentationml/2006/main">
+  <p:cSld>
+    <p:spTree>
+      <p:nvGrpSpPr>
+        <p:cNvPr id="1" name=""/>
+        <p:cNvGrpSpPr/>
+        <p:nvPr/>
+      </p:nvGrpSpPr>
+      <p:grpSpPr>
+        <a:xfrm>
+          <a:off x="0" y="0"/>
+          <a:ext cx="0" cy="0"/>
+          <a:chOff x="0" y="0"/>
+          <a:chExt cx="0" cy="0"/>
+        </a:xfrm>
+      </p:grpSpPr>
+      <p:sp>
+        <p:nvSpPr>
+          <p:cNvPr id="2" name="Title 1">
+            <a:extLst>
+              <a:ext uri="{FF2B5EF4-FFF2-40B4-BE49-F238E27FC236}">
+                <a16:creationId xmlns:a16="http://schemas.microsoft.com/office/drawing/2014/main" id="{C4B9F71C-6E14-327E-49DC-2DDD3B3C1C42}"/>
+              </a:ext>
+            </a:extLst>
+          </p:cNvPr>
+          <p:cNvSpPr>
+            <a:spLocks noGrp="1"/>
+          </p:cNvSpPr>
+          <p:nvPr>
+            <p:ph type="title"/>
+          </p:nvPr>
+        </p:nvSpPr>
+        <p:spPr/>
+        <p:txBody>
+          <a:bodyPr/>
+          <a:lstStyle/>
+          <a:p>
+            <a:r>
+              <a:rPr lang="en-US" dirty="0"/>
+              <a:t>Next Steps</a:t>
+            </a:r>
+          </a:p>
+        </p:txBody>
+      </p:sp>
+      <p:sp>
+        <p:nvSpPr>
+          <p:cNvPr id="3" name="Content Placeholder 2">
+            <a:extLst>
+              <a:ext uri="{FF2B5EF4-FFF2-40B4-BE49-F238E27FC236}">
+                <a16:creationId xmlns:a16="http://schemas.microsoft.com/office/drawing/2014/main" id="{E242FE87-03C0-CFB9-CB5D-5189616B1C34}"/>
+              </a:ext>
+            </a:extLst>
+          </p:cNvPr>
+          <p:cNvSpPr>
+            <a:spLocks noGrp="1"/>
+          </p:cNvSpPr>
+          <p:nvPr>
+            <p:ph idx="1"/>
+          </p:nvPr>
+        </p:nvSpPr>
+        <p:spPr/>
+        <p:txBody>
+          <a:bodyPr/>
+          <a:lstStyle/>
+          <a:p>
+            <a:r>
+              <a:rPr lang="en-US" dirty="0"/>
+              <a:t>Finish the remaining models</a:t>
+            </a:r>
+          </a:p>
+          <a:p>
+            <a:r>
+              <a:rPr lang="en-US" dirty="0"/>
+              <a:t>Test all 3 models after adjusting for skewness (massive outliers in dataset)</a:t>
+            </a:r>
+          </a:p>
+          <a:p>
+            <a:r>
+              <a:rPr lang="en-US" dirty="0"/>
+              <a:t>Adding more features to improve the accuracy score </a:t>
+            </a:r>
+          </a:p>
+          <a:p>
+            <a:endParaRPr lang="en-US" dirty="0"/>
+          </a:p>
+        </p:txBody>
+      </p:sp>
+    </p:spTree>
+    <p:extLst>
+      <p:ext uri="{BB962C8B-B14F-4D97-AF65-F5344CB8AC3E}">
+        <p14:creationId xmlns:p14="http://schemas.microsoft.com/office/powerpoint/2010/main" val="2083120843"/>
       </p:ext>
     </p:extLst>
   </p:cSld>

</xml_diff>

<commit_message>
added plots to dataset
</commit_message>
<xml_diff>
--- a/CSC382 Project Presentation.pptx
+++ b/CSC382 Project Presentation.pptx
@@ -11,10 +11,11 @@
     <p:sldId id="260" r:id="rId5"/>
     <p:sldId id="261" r:id="rId6"/>
     <p:sldId id="264" r:id="rId7"/>
-    <p:sldId id="259" r:id="rId8"/>
-    <p:sldId id="265" r:id="rId9"/>
-    <p:sldId id="262" r:id="rId10"/>
-    <p:sldId id="263" r:id="rId11"/>
+    <p:sldId id="267" r:id="rId8"/>
+    <p:sldId id="259" r:id="rId9"/>
+    <p:sldId id="265" r:id="rId10"/>
+    <p:sldId id="262" r:id="rId11"/>
+    <p:sldId id="263" r:id="rId12"/>
   </p:sldIdLst>
   <p:sldSz cx="12192000" cy="6858000"/>
   <p:notesSz cx="6858000" cy="9144000"/>
@@ -3357,6 +3358,113 @@
           <p:cNvPr id="2" name="Title 1">
             <a:extLst>
               <a:ext uri="{FF2B5EF4-FFF2-40B4-BE49-F238E27FC236}">
+                <a16:creationId xmlns:a16="http://schemas.microsoft.com/office/drawing/2014/main" id="{C4B9F71C-6E14-327E-49DC-2DDD3B3C1C42}"/>
+              </a:ext>
+            </a:extLst>
+          </p:cNvPr>
+          <p:cNvSpPr>
+            <a:spLocks noGrp="1"/>
+          </p:cNvSpPr>
+          <p:nvPr>
+            <p:ph type="title"/>
+          </p:nvPr>
+        </p:nvSpPr>
+        <p:spPr/>
+        <p:txBody>
+          <a:bodyPr/>
+          <a:lstStyle/>
+          <a:p>
+            <a:r>
+              <a:rPr lang="en-US" dirty="0"/>
+              <a:t>Next Steps</a:t>
+            </a:r>
+          </a:p>
+        </p:txBody>
+      </p:sp>
+      <p:sp>
+        <p:nvSpPr>
+          <p:cNvPr id="3" name="Content Placeholder 2">
+            <a:extLst>
+              <a:ext uri="{FF2B5EF4-FFF2-40B4-BE49-F238E27FC236}">
+                <a16:creationId xmlns:a16="http://schemas.microsoft.com/office/drawing/2014/main" id="{E242FE87-03C0-CFB9-CB5D-5189616B1C34}"/>
+              </a:ext>
+            </a:extLst>
+          </p:cNvPr>
+          <p:cNvSpPr>
+            <a:spLocks noGrp="1"/>
+          </p:cNvSpPr>
+          <p:nvPr>
+            <p:ph idx="1"/>
+          </p:nvPr>
+        </p:nvSpPr>
+        <p:spPr/>
+        <p:txBody>
+          <a:bodyPr/>
+          <a:lstStyle/>
+          <a:p>
+            <a:r>
+              <a:rPr lang="en-US" dirty="0"/>
+              <a:t>Finish the linear regression and decision tree models</a:t>
+            </a:r>
+          </a:p>
+          <a:p>
+            <a:r>
+              <a:rPr lang="en-US" dirty="0"/>
+              <a:t>Test for accuracy of the models compared to the baseline model</a:t>
+            </a:r>
+          </a:p>
+          <a:p>
+            <a:r>
+              <a:rPr lang="en-US" dirty="0"/>
+              <a:t>Test all 3 models after adjusting for skewness (massive outliers in dataset)</a:t>
+            </a:r>
+          </a:p>
+          <a:p>
+            <a:r>
+              <a:rPr lang="en-US" dirty="0"/>
+              <a:t>Adding more features to improve the scores overall </a:t>
+            </a:r>
+          </a:p>
+          <a:p>
+            <a:endParaRPr lang="en-US" dirty="0"/>
+          </a:p>
+        </p:txBody>
+      </p:sp>
+    </p:spTree>
+    <p:extLst>
+      <p:ext uri="{BB962C8B-B14F-4D97-AF65-F5344CB8AC3E}">
+        <p14:creationId xmlns:p14="http://schemas.microsoft.com/office/powerpoint/2010/main" val="2083120843"/>
+      </p:ext>
+    </p:extLst>
+  </p:cSld>
+  <p:clrMapOvr>
+    <a:masterClrMapping/>
+  </p:clrMapOvr>
+</p:sld>
+</file>
+
+<file path=ppt/slides/slide11.xml><?xml version="1.0" encoding="utf-8"?>
+<p:sld xmlns:a="http://schemas.openxmlformats.org/drawingml/2006/main" xmlns:r="http://schemas.openxmlformats.org/officeDocument/2006/relationships" xmlns:p="http://schemas.openxmlformats.org/presentationml/2006/main">
+  <p:cSld>
+    <p:spTree>
+      <p:nvGrpSpPr>
+        <p:cNvPr id="1" name=""/>
+        <p:cNvGrpSpPr/>
+        <p:nvPr/>
+      </p:nvGrpSpPr>
+      <p:grpSpPr>
+        <a:xfrm>
+          <a:off x="0" y="0"/>
+          <a:ext cx="0" cy="0"/>
+          <a:chOff x="0" y="0"/>
+          <a:chExt cx="0" cy="0"/>
+        </a:xfrm>
+      </p:grpSpPr>
+      <p:sp>
+        <p:nvSpPr>
+          <p:cNvPr id="2" name="Title 1">
+            <a:extLst>
+              <a:ext uri="{FF2B5EF4-FFF2-40B4-BE49-F238E27FC236}">
                 <a16:creationId xmlns:a16="http://schemas.microsoft.com/office/drawing/2014/main" id="{E8A141B7-AA3E-1139-FB43-816D6EAD4BE2}"/>
               </a:ext>
             </a:extLst>
@@ -4468,6 +4576,124 @@
           <p:cNvPr id="2" name="Title 1">
             <a:extLst>
               <a:ext uri="{FF2B5EF4-FFF2-40B4-BE49-F238E27FC236}">
+                <a16:creationId xmlns:a16="http://schemas.microsoft.com/office/drawing/2014/main" id="{3343E6B7-E4D6-8E52-83AF-1DA58D7BC938}"/>
+              </a:ext>
+            </a:extLst>
+          </p:cNvPr>
+          <p:cNvSpPr>
+            <a:spLocks noGrp="1"/>
+          </p:cNvSpPr>
+          <p:nvPr>
+            <p:ph type="title"/>
+          </p:nvPr>
+        </p:nvSpPr>
+        <p:spPr/>
+        <p:txBody>
+          <a:bodyPr/>
+          <a:lstStyle/>
+          <a:p>
+            <a:r>
+              <a:rPr lang="en-US" dirty="0"/>
+              <a:t>Data Skewness</a:t>
+            </a:r>
+          </a:p>
+        </p:txBody>
+      </p:sp>
+      <p:pic>
+        <p:nvPicPr>
+          <p:cNvPr id="5" name="Picture 4">
+            <a:extLst>
+              <a:ext uri="{FF2B5EF4-FFF2-40B4-BE49-F238E27FC236}">
+                <a16:creationId xmlns:a16="http://schemas.microsoft.com/office/drawing/2014/main" id="{F1DC208E-2C97-6685-C48D-90B63AB8AD92}"/>
+              </a:ext>
+            </a:extLst>
+          </p:cNvPr>
+          <p:cNvPicPr>
+            <a:picLocks noChangeAspect="1"/>
+          </p:cNvPicPr>
+          <p:nvPr/>
+        </p:nvPicPr>
+        <p:blipFill>
+          <a:blip r:embed="rId2"/>
+          <a:stretch>
+            <a:fillRect/>
+          </a:stretch>
+        </p:blipFill>
+        <p:spPr>
+          <a:xfrm>
+            <a:off x="6716234" y="2428086"/>
+            <a:ext cx="5475766" cy="4106825"/>
+          </a:xfrm>
+          <a:prstGeom prst="rect">
+            <a:avLst/>
+          </a:prstGeom>
+        </p:spPr>
+      </p:pic>
+      <p:pic>
+        <p:nvPicPr>
+          <p:cNvPr id="7" name="Picture 6">
+            <a:extLst>
+              <a:ext uri="{FF2B5EF4-FFF2-40B4-BE49-F238E27FC236}">
+                <a16:creationId xmlns:a16="http://schemas.microsoft.com/office/drawing/2014/main" id="{6302DF7D-239C-E4D7-DB6E-3251361B4DDB}"/>
+              </a:ext>
+            </a:extLst>
+          </p:cNvPr>
+          <p:cNvPicPr>
+            <a:picLocks noChangeAspect="1"/>
+          </p:cNvPicPr>
+          <p:nvPr/>
+        </p:nvPicPr>
+        <p:blipFill>
+          <a:blip r:embed="rId3"/>
+          <a:stretch>
+            <a:fillRect/>
+          </a:stretch>
+        </p:blipFill>
+        <p:spPr>
+          <a:xfrm>
+            <a:off x="1" y="2428086"/>
+            <a:ext cx="5475766" cy="4106825"/>
+          </a:xfrm>
+          <a:prstGeom prst="rect">
+            <a:avLst/>
+          </a:prstGeom>
+        </p:spPr>
+      </p:pic>
+    </p:spTree>
+    <p:extLst>
+      <p:ext uri="{BB962C8B-B14F-4D97-AF65-F5344CB8AC3E}">
+        <p14:creationId xmlns:p14="http://schemas.microsoft.com/office/powerpoint/2010/main" val="805091782"/>
+      </p:ext>
+    </p:extLst>
+  </p:cSld>
+  <p:clrMapOvr>
+    <a:masterClrMapping/>
+  </p:clrMapOvr>
+</p:sld>
+</file>
+
+<file path=ppt/slides/slide8.xml><?xml version="1.0" encoding="utf-8"?>
+<p:sld xmlns:a="http://schemas.openxmlformats.org/drawingml/2006/main" xmlns:r="http://schemas.openxmlformats.org/officeDocument/2006/relationships" xmlns:p="http://schemas.openxmlformats.org/presentationml/2006/main">
+  <p:cSld>
+    <p:spTree>
+      <p:nvGrpSpPr>
+        <p:cNvPr id="1" name=""/>
+        <p:cNvGrpSpPr/>
+        <p:nvPr/>
+      </p:nvGrpSpPr>
+      <p:grpSpPr>
+        <a:xfrm>
+          <a:off x="0" y="0"/>
+          <a:ext cx="0" cy="0"/>
+          <a:chOff x="0" y="0"/>
+          <a:chExt cx="0" cy="0"/>
+        </a:xfrm>
+      </p:grpSpPr>
+      <p:sp>
+        <p:nvSpPr>
+          <p:cNvPr id="2" name="Title 1">
+            <a:extLst>
+              <a:ext uri="{FF2B5EF4-FFF2-40B4-BE49-F238E27FC236}">
                 <a16:creationId xmlns:a16="http://schemas.microsoft.com/office/drawing/2014/main" id="{539C3C95-044A-1504-C0AC-95662A05CFB5}"/>
               </a:ext>
             </a:extLst>
@@ -4664,7 +4890,7 @@
 </p:sld>
 </file>
 
-<file path=ppt/slides/slide8.xml><?xml version="1.0" encoding="utf-8"?>
+<file path=ppt/slides/slide9.xml><?xml version="1.0" encoding="utf-8"?>
 <p:sld xmlns:a="http://schemas.openxmlformats.org/drawingml/2006/main" xmlns:r="http://schemas.openxmlformats.org/officeDocument/2006/relationships" xmlns:p="http://schemas.openxmlformats.org/presentationml/2006/main">
   <p:cSld>
     <p:spTree>
@@ -4881,107 +5107,6 @@
     <p:extLst>
       <p:ext uri="{BB962C8B-B14F-4D97-AF65-F5344CB8AC3E}">
         <p14:creationId xmlns:p14="http://schemas.microsoft.com/office/powerpoint/2010/main" val="264224054"/>
-      </p:ext>
-    </p:extLst>
-  </p:cSld>
-  <p:clrMapOvr>
-    <a:masterClrMapping/>
-  </p:clrMapOvr>
-</p:sld>
-</file>
-
-<file path=ppt/slides/slide9.xml><?xml version="1.0" encoding="utf-8"?>
-<p:sld xmlns:a="http://schemas.openxmlformats.org/drawingml/2006/main" xmlns:r="http://schemas.openxmlformats.org/officeDocument/2006/relationships" xmlns:p="http://schemas.openxmlformats.org/presentationml/2006/main">
-  <p:cSld>
-    <p:spTree>
-      <p:nvGrpSpPr>
-        <p:cNvPr id="1" name=""/>
-        <p:cNvGrpSpPr/>
-        <p:nvPr/>
-      </p:nvGrpSpPr>
-      <p:grpSpPr>
-        <a:xfrm>
-          <a:off x="0" y="0"/>
-          <a:ext cx="0" cy="0"/>
-          <a:chOff x="0" y="0"/>
-          <a:chExt cx="0" cy="0"/>
-        </a:xfrm>
-      </p:grpSpPr>
-      <p:sp>
-        <p:nvSpPr>
-          <p:cNvPr id="2" name="Title 1">
-            <a:extLst>
-              <a:ext uri="{FF2B5EF4-FFF2-40B4-BE49-F238E27FC236}">
-                <a16:creationId xmlns:a16="http://schemas.microsoft.com/office/drawing/2014/main" id="{C4B9F71C-6E14-327E-49DC-2DDD3B3C1C42}"/>
-              </a:ext>
-            </a:extLst>
-          </p:cNvPr>
-          <p:cNvSpPr>
-            <a:spLocks noGrp="1"/>
-          </p:cNvSpPr>
-          <p:nvPr>
-            <p:ph type="title"/>
-          </p:nvPr>
-        </p:nvSpPr>
-        <p:spPr/>
-        <p:txBody>
-          <a:bodyPr/>
-          <a:lstStyle/>
-          <a:p>
-            <a:r>
-              <a:rPr lang="en-US" dirty="0"/>
-              <a:t>Next Steps</a:t>
-            </a:r>
-          </a:p>
-        </p:txBody>
-      </p:sp>
-      <p:sp>
-        <p:nvSpPr>
-          <p:cNvPr id="3" name="Content Placeholder 2">
-            <a:extLst>
-              <a:ext uri="{FF2B5EF4-FFF2-40B4-BE49-F238E27FC236}">
-                <a16:creationId xmlns:a16="http://schemas.microsoft.com/office/drawing/2014/main" id="{E242FE87-03C0-CFB9-CB5D-5189616B1C34}"/>
-              </a:ext>
-            </a:extLst>
-          </p:cNvPr>
-          <p:cNvSpPr>
-            <a:spLocks noGrp="1"/>
-          </p:cNvSpPr>
-          <p:nvPr>
-            <p:ph idx="1"/>
-          </p:nvPr>
-        </p:nvSpPr>
-        <p:spPr/>
-        <p:txBody>
-          <a:bodyPr/>
-          <a:lstStyle/>
-          <a:p>
-            <a:r>
-              <a:rPr lang="en-US" dirty="0"/>
-              <a:t>Finish the remaining models</a:t>
-            </a:r>
-          </a:p>
-          <a:p>
-            <a:r>
-              <a:rPr lang="en-US" dirty="0"/>
-              <a:t>Test all 3 models after adjusting for skewness (massive outliers in dataset)</a:t>
-            </a:r>
-          </a:p>
-          <a:p>
-            <a:r>
-              <a:rPr lang="en-US" dirty="0"/>
-              <a:t>Adding more features to improve the accuracy score </a:t>
-            </a:r>
-          </a:p>
-          <a:p>
-            <a:endParaRPr lang="en-US" dirty="0"/>
-          </a:p>
-        </p:txBody>
-      </p:sp>
-    </p:spTree>
-    <p:extLst>
-      <p:ext uri="{BB962C8B-B14F-4D97-AF65-F5344CB8AC3E}">
-        <p14:creationId xmlns:p14="http://schemas.microsoft.com/office/powerpoint/2010/main" val="2083120843"/>
       </p:ext>
     </p:extLst>
   </p:cSld>

</xml_diff>